<commit_message>
Add segmentation bridge to mentor deck
</commit_message>
<xml_diff>
--- a/docs/Mentor_Uplift_Presentation_15min.pptx
+++ b/docs/Mentor_Uplift_Presentation_15min.pptx
@@ -620,12 +620,14 @@
           <a:p>
             <a:r>
               <a:rPr lang="vi-VN"/>
-              <a:t>Thời lượng: 60 giây
-A/B evidence cho thấy Raw ATE khoảng 0,96 và Adjusted ATE khoảng 0,95 chuyến trên khách hàng trong 30 ngày. Khoảng tin cậy không chứa 0 nên tác động trung bình có ý nghĩa thống kê.
-Nhưng ATE chỉ trả lời mức tăng trung bình. Nó chưa nói khách hàng nào phản ứng mạnh và khách hàng nào vốn vẫn đi xe dù không có voucher.
-Chuyển: Vì vậy project chuyển từ ATE sang CATE và so sánh các uplift learners.
+              <a:t>Thời lượng: 75 giây
+A/B evidence cho thấy Adjusted ATE khoảng 0,95 chuyến trên khách hàng trong 30 ngày và khoảng tin cậy không chứa 0. Voucher thực sự tạo uplift trung bình.
+Tiếp theo, project phân tích năm persona: Suburban Card, Suburban Cash, Rain Riders, Airport Business và Urban Regulars. Cả năm nhóm đều có ATE dương, nhưng khi tính contribution margin trừ voucher burn thì ROI vẫn âm. Ngay cả nhóm tốt nhất là Suburban Card cũng có ROI -7,5%.
+Ý nghĩa: segmentation giúp nhìn thấy khác biệt giữa các nhóm, nhưng rule theo persona vẫn quá thô. Trong cùng một segment vẫn có người phản ứng tốt, người phản ứng kém và người vốn sẽ tự đi xe.
+Demo tùy thời gian: mở Tab 2 khoảng 30 giây để chỉ bảng Segment Economics, sau đó chuyển thẳng sang slide model.
+Chuyển: Vì vậy project cần CATE và EV ở cấp khách hàng, thay vì chỉ target toàn bộ một segment.
 [Sources]
-docs/Week4_AA_AB_Testing_Report.md; src/dashboard/app.py</a:t>
+docs/Week4_AA_AB_Testing_Report.md; src/dashboard/app.py; data/processed/segmented_simulation_data.csv</a:t>
             </a:r>
             <a:endParaRPr lang="en-US"/>
           </a:p>
@@ -5216,7 +5218,7 @@
         <p:spPr>
           <a:xfrm>
             <a:off x="640079" y="182880"/>
-            <a:ext cx="7791685" cy="492443"/>
+            <a:ext cx="8420382" cy="492443"/>
           </a:xfrm>
           <a:prstGeom prst="rect">
             <a:avLst/>
@@ -5243,7 +5245,7 @@
                   <a:srgbClr val="FFFFFF"/>
                 </a:solidFill>
               </a:rPr>
-              <a:t>2. ATE dương nhưng chưa trả lời nên phát cho ai</a:t>
+              <a:t>2. ATE dương nhưng segment targeting vẫn chưa đủ</a:t>
             </a:r>
             <a:endParaRPr sz="2600" b="1">
               <a:solidFill>
@@ -5262,7 +5264,7 @@
         <p:spPr>
           <a:xfrm>
             <a:off x="640080" y="731520"/>
-            <a:ext cx="5186805" cy="292388"/>
+            <a:ext cx="4456220" cy="292388"/>
           </a:xfrm>
           <a:prstGeom prst="rect">
             <a:avLst/>
@@ -5284,12 +5286,12 @@
               </a:defRPr>
             </a:pPr>
             <a:r>
-              <a:rPr lang="en-US">
+              <a:rPr lang="vi-VN">
                 <a:solidFill>
                   <a:srgbClr val="FFFFFF"/>
                 </a:solidFill>
               </a:rPr>
-              <a:t>A/B evidence xác nhận tác động; heterogeneity quyết định targeting</a:t>
+              <a:t>Hiệu ứng tồn tại ở mọi persona, nhưng economics vẫn âm</a:t>
             </a:r>
             <a:endParaRPr>
               <a:solidFill>
@@ -5712,7 +5714,7 @@
         <p:spPr>
           <a:xfrm>
             <a:off x="685800" y="2286000"/>
-            <a:ext cx="2590800" cy="861774"/>
+            <a:ext cx="2590800" cy="1092607"/>
           </a:xfrm>
           <a:prstGeom prst="rect">
             <a:avLst/>
@@ -5742,7 +5744,7 @@
                   <a:srgbClr val="FFFFFF"/>
                 </a:solidFill>
               </a:rPr>
-              <a:t>• Raw ATE: 0,96 chuyến.</a:t>
+              <a:t>• Adjusted ATE: 0,95 chuyến/30 ngày.</a:t>
             </a:r>
           </a:p>
           <a:p>
@@ -5763,7 +5765,7 @@
                   <a:srgbClr val="FFFFFF"/>
                 </a:solidFill>
               </a:rPr>
-              <a:t>• Adjusted ATE: 0,95 chuyến/30 ngày.</a:t>
+              <a:t>• Khoảng tin cậy 95%: [0,76; 1,14].</a:t>
             </a:r>
             <a:endParaRPr>
               <a:solidFill>
@@ -5897,7 +5899,7 @@
                   <a:srgbClr val="FFFFFF"/>
                 </a:solidFill>
               </a:rPr>
-              <a:t>Độ tin cậy</a:t>
+              <a:t>Segment ROI</a:t>
             </a:r>
             <a:endParaRPr>
               <a:solidFill>
@@ -5916,7 +5918,7 @@
         <p:spPr>
           <a:xfrm>
             <a:off x="3550920" y="2286000"/>
-            <a:ext cx="2590800" cy="923330"/>
+            <a:ext cx="2590800" cy="830997"/>
           </a:xfrm>
           <a:prstGeom prst="rect">
             <a:avLst/>
@@ -5930,24 +5932,34 @@
           <a:lstStyle/>
           <a:p>
             <a:r>
-              <a:rPr lang="en-US">
+              <a:rPr lang="en-US" sz="1600">
                 <a:solidFill>
                   <a:srgbClr val="FFFFFF"/>
                 </a:solidFill>
               </a:rPr>
-              <a:t>• Khoảng tin cậy 95%: [0,76; 1,14].</a:t>
-            </a:r>
-          </a:p>
-          <a:p>
-            <a:r>
-              <a:rPr lang="en-US">
+              <a:t>• Suburban Card: -7,5%.</a:t>
+            </a:r>
+          </a:p>
+          <a:p>
+            <a:r>
+              <a:rPr lang="en-US" sz="1600">
                 <a:solidFill>
                   <a:srgbClr val="FFFFFF"/>
                 </a:solidFill>
               </a:rPr>
-              <a:t>• P-value &lt; 0,001.</a:t>
-            </a:r>
-            <a:endParaRPr>
+              <a:t>• Airport Business: -63,2%.</a:t>
+            </a:r>
+          </a:p>
+          <a:p>
+            <a:r>
+              <a:rPr lang="en-US" sz="1600">
+                <a:solidFill>
+                  <a:srgbClr val="FFFFFF"/>
+                </a:solidFill>
+              </a:rPr>
+              <a:t>• Urban Regulars: -73,1%.</a:t>
+            </a:r>
+            <a:endParaRPr sz="1600">
               <a:solidFill>
                 <a:srgbClr val="FFFFFF"/>
               </a:solidFill>
@@ -6079,7 +6091,7 @@
                   <a:srgbClr val="FFFFFF"/>
                 </a:solidFill>
               </a:rPr>
-              <a:t>Điểm chưa đủ</a:t>
+              <a:t>Khoảng trống</a:t>
             </a:r>
             <a:endParaRPr>
               <a:solidFill>
@@ -6098,7 +6110,7 @@
         <p:spPr>
           <a:xfrm>
             <a:off x="6416040" y="2286000"/>
-            <a:ext cx="2590800" cy="1200329"/>
+            <a:ext cx="2590800" cy="1477328"/>
           </a:xfrm>
           <a:prstGeom prst="rect">
             <a:avLst/>
@@ -6112,22 +6124,22 @@
           <a:lstStyle/>
           <a:p>
             <a:r>
-              <a:rPr lang="en-US">
+              <a:rPr lang="vi-VN">
                 <a:solidFill>
                   <a:srgbClr val="FFFFFF"/>
                 </a:solidFill>
               </a:rPr>
-              <a:t>• ATE là mức trung bình.</a:t>
-            </a:r>
-          </a:p>
-          <a:p>
-            <a:r>
-              <a:rPr lang="en-US">
+              <a:t>• Cả 5 persona có ATE dương nhưng ROI âm.</a:t>
+            </a:r>
+          </a:p>
+          <a:p>
+            <a:r>
+              <a:rPr lang="vi-VN">
                 <a:solidFill>
                   <a:srgbClr val="FFFFFF"/>
                 </a:solidFill>
               </a:rPr>
-              <a:t>• Cần CATE để tìm nhóm response đủ lớn và có lời.</a:t>
+              <a:t>• Segment rule quá thô; cần CATE + EV ở cấp user.</a:t>
             </a:r>
             <a:endParaRPr>
               <a:solidFill>

</xml_diff>